<commit_message>
docs: add urban dreams design plan and update course PPT
- Add game design plan document for Urban Dreams project
- Update Vibe Agentic Coding course presentation

Co-Authored-By: Claude Opus 4.6 <noreply@anthropic.com>
</commit_message>
<xml_diff>
--- a/Tutorial-0/Vibe_Agentic Coding 课程PPT.pptx
+++ b/Tutorial-0/Vibe_Agentic Coding 课程PPT.pptx
@@ -250,7 +250,7 @@
   <p:extLst>
     <p:ext uri="{EFAFB233-063F-42B5-8137-9DF3F51BA10A}">
       <p15:sldGuideLst xmlns:p15="http://schemas.microsoft.com/office/powerpoint/2012/main">
-        <p15:guide id="1" orient="horz" pos="1600" userDrawn="1">
+        <p15:guide id="1" orient="horz" pos="1624" userDrawn="1">
           <p15:clr>
             <a:srgbClr val="747775"/>
           </p15:clr>
@@ -14010,7 +14010,7 @@
                 <a:cs typeface="Noto Sans SC" panose="020B0200000000000000" charset="-122"/>
                 <a:sym typeface="Noto Sans SC" panose="020B0200000000000000" charset="-122"/>
               </a:rPr>
-              <a:t>写进简历，面试应该会有加分的</a:t>
+              <a:t>写进简历，面试应该会有加分</a:t>
             </a:r>
             <a:endParaRPr lang="zh-CN" altLang="en-US" sz="1400" b="0" i="0" u="none" strike="noStrike">
               <a:solidFill>
@@ -14068,7 +14068,7 @@
         <p:spPr>
           <a:xfrm>
             <a:off x="762000" y="508000"/>
-            <a:ext cx="2679700" cy="431800"/>
+            <a:ext cx="3632200" cy="431800"/>
           </a:xfrm>
           <a:prstGeom prst="rect">
             <a:avLst/>
@@ -14100,9 +14100,29 @@
                 <a:cs typeface="Noto Sans SC" panose="020B0200000000000000" charset="-122"/>
                 <a:sym typeface="Noto Sans SC" panose="020B0200000000000000" charset="-122"/>
               </a:rPr>
-              <a:t>四周核心学习路径</a:t>
+              <a:t>四周</a:t>
             </a:r>
-            <a:endParaRPr lang="en-US" sz="1100"/>
+            <a:r>
+              <a:rPr lang="zh-CN" altLang="en-US" sz="2400" b="1" i="0" u="none" strike="noStrike">
+                <a:solidFill>
+                  <a:srgbClr val="000000"/>
+                </a:solidFill>
+                <a:latin typeface="Noto Sans SC" panose="020B0200000000000000" charset="-122"/>
+                <a:ea typeface="Noto Sans SC" panose="020B0200000000000000" charset="-122"/>
+                <a:cs typeface="Noto Sans SC" panose="020B0200000000000000" charset="-122"/>
+                <a:sym typeface="Noto Sans SC" panose="020B0200000000000000" charset="-122"/>
+              </a:rPr>
+              <a:t>规划（可能有调整）</a:t>
+            </a:r>
+            <a:endParaRPr lang="zh-CN" altLang="en-US" sz="2400" b="1" i="0" u="none" strike="noStrike">
+              <a:solidFill>
+                <a:srgbClr val="000000"/>
+              </a:solidFill>
+              <a:latin typeface="Noto Sans SC" panose="020B0200000000000000" charset="-122"/>
+              <a:ea typeface="Noto Sans SC" panose="020B0200000000000000" charset="-122"/>
+              <a:cs typeface="Noto Sans SC" panose="020B0200000000000000" charset="-122"/>
+              <a:sym typeface="Noto Sans SC" panose="020B0200000000000000" charset="-122"/>
+            </a:endParaRPr>
           </a:p>
         </p:txBody>
       </p:sp>
@@ -14236,9 +14256,17 @@
                 <a:cs typeface="Noto Sans SC" panose="020B0200000000000000" charset="-122"/>
                 <a:sym typeface="Noto Sans SC" panose="020B0200000000000000" charset="-122"/>
               </a:rPr>
-              <a:t>第一周：Trae基本使用</a:t>
+              <a:t>第一周：Trae基本使用+AGENT</a:t>
             </a:r>
-            <a:endParaRPr lang="en-US" sz="1100"/>
+            <a:endParaRPr lang="zh-CN" altLang="en-US" sz="1600" b="1" i="0" u="none" strike="noStrike">
+              <a:solidFill>
+                <a:srgbClr val="000000"/>
+              </a:solidFill>
+              <a:latin typeface="Noto Sans SC" panose="020B0200000000000000" charset="-122"/>
+              <a:ea typeface="Noto Sans SC" panose="020B0200000000000000" charset="-122"/>
+              <a:cs typeface="Noto Sans SC" panose="020B0200000000000000" charset="-122"/>
+              <a:sym typeface="Noto Sans SC" panose="020B0200000000000000" charset="-122"/>
+            </a:endParaRPr>
           </a:p>
         </p:txBody>
       </p:sp>
@@ -14372,9 +14400,47 @@
                 <a:cs typeface="Noto Sans SC" panose="020B0200000000000000" charset="-122"/>
                 <a:sym typeface="Noto Sans SC" panose="020B0200000000000000" charset="-122"/>
               </a:rPr>
-              <a:t>第二周：AGENT + skill</a:t>
+              <a:t>第二周： </a:t>
             </a:r>
-            <a:endParaRPr lang="en-US" sz="1100"/>
+            <a:r>
+              <a:rPr lang="zh-CN" altLang="en-US" sz="1600" b="1">
+                <a:latin typeface="Noto Sans SC" panose="020B0200000000000000" charset="-122"/>
+                <a:ea typeface="Noto Sans SC" panose="020B0200000000000000" charset="-122"/>
+                <a:cs typeface="Noto Sans SC" panose="020B0200000000000000" charset="-122"/>
+                <a:sym typeface="Noto Sans SC" panose="020B0200000000000000" charset="-122"/>
+              </a:rPr>
+              <a:t>子代理</a:t>
+            </a:r>
+            <a:r>
+              <a:rPr lang="en-US" altLang="zh-CN" sz="1600" b="1">
+                <a:latin typeface="Noto Sans SC" panose="020B0200000000000000" charset="-122"/>
+                <a:ea typeface="Noto Sans SC" panose="020B0200000000000000" charset="-122"/>
+                <a:cs typeface="Noto Sans SC" panose="020B0200000000000000" charset="-122"/>
+                <a:sym typeface="Noto Sans SC" panose="020B0200000000000000" charset="-122"/>
+              </a:rPr>
+              <a:t>+</a:t>
+            </a:r>
+            <a:r>
+              <a:rPr lang="en-US" sz="1600" b="1" i="0" u="none" strike="noStrike">
+                <a:solidFill>
+                  <a:srgbClr val="000000"/>
+                </a:solidFill>
+                <a:latin typeface="Noto Sans SC" panose="020B0200000000000000" charset="-122"/>
+                <a:ea typeface="Noto Sans SC" panose="020B0200000000000000" charset="-122"/>
+                <a:cs typeface="Noto Sans SC" panose="020B0200000000000000" charset="-122"/>
+                <a:sym typeface="Noto Sans SC" panose="020B0200000000000000" charset="-122"/>
+              </a:rPr>
+              <a:t>skill</a:t>
+            </a:r>
+            <a:endParaRPr lang="zh-CN" altLang="en-US" sz="1600" b="1" i="0" u="none" strike="noStrike">
+              <a:solidFill>
+                <a:srgbClr val="000000"/>
+              </a:solidFill>
+              <a:latin typeface="Noto Sans SC" panose="020B0200000000000000" charset="-122"/>
+              <a:ea typeface="Noto Sans SC" panose="020B0200000000000000" charset="-122"/>
+              <a:cs typeface="Noto Sans SC" panose="020B0200000000000000" charset="-122"/>
+              <a:sym typeface="Noto Sans SC" panose="020B0200000000000000" charset="-122"/>
+            </a:endParaRPr>
           </a:p>
         </p:txBody>
       </p:sp>
@@ -14977,8 +15043,8 @@
               </a:tblPr>
               <a:tblGrid>
                 <a:gridCol w="2032000"/>
-                <a:gridCol w="4191000"/>
-                <a:gridCol w="4191000"/>
+                <a:gridCol w="4181475"/>
+                <a:gridCol w="4200525"/>
               </a:tblGrid>
               <a:tr h="508000">
                 <a:tc>
@@ -15526,7 +15592,7 @@
                           <a:cs typeface="Noto Sans SC" panose="020B0200000000000000" charset="-122"/>
                           <a:sym typeface="Noto Sans SC" panose="020B0200000000000000" charset="-122"/>
                         </a:rPr>
-                        <a:t>Claude</a:t>
+                        <a:t>Claude Code</a:t>
                       </a:r>
                       <a:endParaRPr lang="en-US" sz="1100"/>
                     </a:p>
@@ -16000,7 +16066,7 @@
                 <a:cs typeface="Noto Sans SC" panose="020B0200000000000000" charset="-122"/>
                 <a:sym typeface="Noto Sans SC" panose="020B0200000000000000" charset="-122"/>
               </a:rPr>
-              <a:t>免费额度体验（低成本试学）</a:t>
+              <a:t>免费额度体验</a:t>
             </a:r>
             <a:endParaRPr lang="en-US" sz="1100"/>
           </a:p>
@@ -17783,6 +17849,42 @@
               </a:lnSpc>
               <a:defRPr/>
             </a:pPr>
+            <a:r>
+              <a:rPr lang="en-US" altLang="zh-CN" sz="1400" b="0" i="0" u="none" strike="noStrike">
+                <a:solidFill>
+                  <a:srgbClr val="646A73"/>
+                </a:solidFill>
+                <a:latin typeface="Noto Sans SC" panose="020B0200000000000000" charset="-122"/>
+                <a:ea typeface="Noto Sans SC" panose="020B0200000000000000" charset="-122"/>
+                <a:cs typeface="Noto Sans SC" panose="020B0200000000000000" charset="-122"/>
+                <a:sym typeface="Noto Sans SC" panose="020B0200000000000000" charset="-122"/>
+              </a:rPr>
+              <a:t>UE</a:t>
+            </a:r>
+            <a:r>
+              <a:rPr lang="zh-CN" altLang="en-US" sz="1400" b="0" i="0" u="none" strike="noStrike">
+                <a:solidFill>
+                  <a:srgbClr val="646A73"/>
+                </a:solidFill>
+                <a:latin typeface="Noto Sans SC" panose="020B0200000000000000" charset="-122"/>
+                <a:ea typeface="Noto Sans SC" panose="020B0200000000000000" charset="-122"/>
+                <a:cs typeface="Noto Sans SC" panose="020B0200000000000000" charset="-122"/>
+                <a:sym typeface="Noto Sans SC" panose="020B0200000000000000" charset="-122"/>
+              </a:rPr>
+              <a:t>和</a:t>
+            </a:r>
+            <a:r>
+              <a:rPr lang="en-US" altLang="zh-CN" sz="1400" b="0" i="0" u="none" strike="noStrike">
+                <a:solidFill>
+                  <a:srgbClr val="646A73"/>
+                </a:solidFill>
+                <a:latin typeface="Noto Sans SC" panose="020B0200000000000000" charset="-122"/>
+                <a:ea typeface="Noto Sans SC" panose="020B0200000000000000" charset="-122"/>
+                <a:cs typeface="Noto Sans SC" panose="020B0200000000000000" charset="-122"/>
+                <a:sym typeface="Noto Sans SC" panose="020B0200000000000000" charset="-122"/>
+              </a:rPr>
+              <a:t>Unity</a:t>
+            </a:r>
             <a:r>
               <a:rPr lang="zh-CN" altLang="en-US" sz="1400" b="0" i="0" u="none" strike="noStrike">
                 <a:solidFill>
@@ -18087,43 +18189,43 @@
 
 <file path=ppt/tags/tag43.xml><?xml version="1.0" encoding="utf-8"?>
 <p:tagLst xmlns:p="http://schemas.openxmlformats.org/presentationml/2006/main">
-  <p:tag name="KSO_WM_DIAGRAM_VIRTUALLY_FRAME" val="{&quot;height&quot;:220,&quot;left&quot;:60,&quot;top&quot;:120,&quot;width&quot;:840}"/>
+  <p:tag name="KSO_WM_DIAGRAM_VIRTUALLY_FRAME" val="{&quot;height&quot;:268,&quot;left&quot;:60,&quot;top&quot;:120,&quot;width&quot;:840}"/>
 </p:tagLst>
 </file>
 
 <file path=ppt/tags/tag44.xml><?xml version="1.0" encoding="utf-8"?>
 <p:tagLst xmlns:p="http://schemas.openxmlformats.org/presentationml/2006/main">
-  <p:tag name="KSO_WM_DIAGRAM_VIRTUALLY_FRAME" val="{&quot;height&quot;:220,&quot;left&quot;:60,&quot;top&quot;:120,&quot;width&quot;:840}"/>
+  <p:tag name="KSO_WM_DIAGRAM_VIRTUALLY_FRAME" val="{&quot;height&quot;:268,&quot;left&quot;:60,&quot;top&quot;:120,&quot;width&quot;:840}"/>
 </p:tagLst>
 </file>
 
 <file path=ppt/tags/tag45.xml><?xml version="1.0" encoding="utf-8"?>
 <p:tagLst xmlns:p="http://schemas.openxmlformats.org/presentationml/2006/main">
-  <p:tag name="KSO_WM_DIAGRAM_VIRTUALLY_FRAME" val="{&quot;height&quot;:220,&quot;left&quot;:60,&quot;top&quot;:120,&quot;width&quot;:840}"/>
+  <p:tag name="KSO_WM_DIAGRAM_VIRTUALLY_FRAME" val="{&quot;height&quot;:268,&quot;left&quot;:60,&quot;top&quot;:120,&quot;width&quot;:840}"/>
 </p:tagLst>
 </file>
 
 <file path=ppt/tags/tag46.xml><?xml version="1.0" encoding="utf-8"?>
 <p:tagLst xmlns:p="http://schemas.openxmlformats.org/presentationml/2006/main">
-  <p:tag name="KSO_WM_DIAGRAM_VIRTUALLY_FRAME" val="{&quot;height&quot;:220,&quot;left&quot;:60,&quot;top&quot;:120,&quot;width&quot;:840}"/>
+  <p:tag name="KSO_WM_DIAGRAM_VIRTUALLY_FRAME" val="{&quot;height&quot;:268,&quot;left&quot;:60,&quot;top&quot;:120,&quot;width&quot;:840}"/>
 </p:tagLst>
 </file>
 
 <file path=ppt/tags/tag47.xml><?xml version="1.0" encoding="utf-8"?>
 <p:tagLst xmlns:p="http://schemas.openxmlformats.org/presentationml/2006/main">
-  <p:tag name="KSO_WM_DIAGRAM_VIRTUALLY_FRAME" val="{&quot;height&quot;:220,&quot;left&quot;:60,&quot;top&quot;:120,&quot;width&quot;:840}"/>
+  <p:tag name="KSO_WM_DIAGRAM_VIRTUALLY_FRAME" val="{&quot;height&quot;:268,&quot;left&quot;:60,&quot;top&quot;:120,&quot;width&quot;:840}"/>
 </p:tagLst>
 </file>
 
 <file path=ppt/tags/tag48.xml><?xml version="1.0" encoding="utf-8"?>
 <p:tagLst xmlns:p="http://schemas.openxmlformats.org/presentationml/2006/main">
-  <p:tag name="KSO_WM_DIAGRAM_VIRTUALLY_FRAME" val="{&quot;height&quot;:220,&quot;left&quot;:60,&quot;top&quot;:120,&quot;width&quot;:840}"/>
+  <p:tag name="KSO_WM_DIAGRAM_VIRTUALLY_FRAME" val="{&quot;height&quot;:268,&quot;left&quot;:60,&quot;top&quot;:120,&quot;width&quot;:840}"/>
 </p:tagLst>
 </file>
 
 <file path=ppt/tags/tag49.xml><?xml version="1.0" encoding="utf-8"?>
 <p:tagLst xmlns:p="http://schemas.openxmlformats.org/presentationml/2006/main">
-  <p:tag name="KSO_WM_DIAGRAM_VIRTUALLY_FRAME" val="{&quot;height&quot;:220,&quot;left&quot;:60,&quot;top&quot;:120,&quot;width&quot;:840}"/>
+  <p:tag name="KSO_WM_DIAGRAM_VIRTUALLY_FRAME" val="{&quot;height&quot;:268,&quot;left&quot;:60,&quot;top&quot;:120,&quot;width&quot;:840}"/>
 </p:tagLst>
 </file>
 
@@ -18135,49 +18237,49 @@
 
 <file path=ppt/tags/tag50.xml><?xml version="1.0" encoding="utf-8"?>
 <p:tagLst xmlns:p="http://schemas.openxmlformats.org/presentationml/2006/main">
-  <p:tag name="KSO_WM_DIAGRAM_VIRTUALLY_FRAME" val="{&quot;height&quot;:220,&quot;left&quot;:60,&quot;top&quot;:120,&quot;width&quot;:840}"/>
+  <p:tag name="KSO_WM_DIAGRAM_VIRTUALLY_FRAME" val="{&quot;height&quot;:268,&quot;left&quot;:60,&quot;top&quot;:120,&quot;width&quot;:840}"/>
 </p:tagLst>
 </file>
 
 <file path=ppt/tags/tag51.xml><?xml version="1.0" encoding="utf-8"?>
 <p:tagLst xmlns:p="http://schemas.openxmlformats.org/presentationml/2006/main">
-  <p:tag name="KSO_WM_DIAGRAM_VIRTUALLY_FRAME" val="{&quot;height&quot;:220,&quot;left&quot;:60,&quot;top&quot;:120,&quot;width&quot;:840}"/>
+  <p:tag name="KSO_WM_DIAGRAM_VIRTUALLY_FRAME" val="{&quot;height&quot;:268,&quot;left&quot;:60,&quot;top&quot;:120,&quot;width&quot;:840}"/>
 </p:tagLst>
 </file>
 
 <file path=ppt/tags/tag52.xml><?xml version="1.0" encoding="utf-8"?>
 <p:tagLst xmlns:p="http://schemas.openxmlformats.org/presentationml/2006/main">
-  <p:tag name="KSO_WM_DIAGRAM_VIRTUALLY_FRAME" val="{&quot;height&quot;:220,&quot;left&quot;:60,&quot;top&quot;:120,&quot;width&quot;:840}"/>
+  <p:tag name="KSO_WM_DIAGRAM_VIRTUALLY_FRAME" val="{&quot;height&quot;:268,&quot;left&quot;:60,&quot;top&quot;:120,&quot;width&quot;:840}"/>
 </p:tagLst>
 </file>
 
 <file path=ppt/tags/tag53.xml><?xml version="1.0" encoding="utf-8"?>
 <p:tagLst xmlns:p="http://schemas.openxmlformats.org/presentationml/2006/main">
-  <p:tag name="KSO_WM_DIAGRAM_VIRTUALLY_FRAME" val="{&quot;height&quot;:220,&quot;left&quot;:60,&quot;top&quot;:120,&quot;width&quot;:840}"/>
+  <p:tag name="KSO_WM_DIAGRAM_VIRTUALLY_FRAME" val="{&quot;height&quot;:268,&quot;left&quot;:60,&quot;top&quot;:120,&quot;width&quot;:840}"/>
 </p:tagLst>
 </file>
 
 <file path=ppt/tags/tag54.xml><?xml version="1.0" encoding="utf-8"?>
 <p:tagLst xmlns:p="http://schemas.openxmlformats.org/presentationml/2006/main">
-  <p:tag name="KSO_WM_DIAGRAM_VIRTUALLY_FRAME" val="{&quot;height&quot;:220,&quot;left&quot;:60,&quot;top&quot;:120,&quot;width&quot;:840}"/>
+  <p:tag name="KSO_WM_DIAGRAM_VIRTUALLY_FRAME" val="{&quot;height&quot;:268,&quot;left&quot;:60,&quot;top&quot;:120,&quot;width&quot;:840}"/>
 </p:tagLst>
 </file>
 
 <file path=ppt/tags/tag55.xml><?xml version="1.0" encoding="utf-8"?>
 <p:tagLst xmlns:p="http://schemas.openxmlformats.org/presentationml/2006/main">
-  <p:tag name="KSO_WM_DIAGRAM_VIRTUALLY_FRAME" val="{&quot;height&quot;:220,&quot;left&quot;:60,&quot;top&quot;:120,&quot;width&quot;:840}"/>
+  <p:tag name="KSO_WM_DIAGRAM_VIRTUALLY_FRAME" val="{&quot;height&quot;:268,&quot;left&quot;:60,&quot;top&quot;:120,&quot;width&quot;:840}"/>
 </p:tagLst>
 </file>
 
 <file path=ppt/tags/tag56.xml><?xml version="1.0" encoding="utf-8"?>
 <p:tagLst xmlns:p="http://schemas.openxmlformats.org/presentationml/2006/main">
-  <p:tag name="KSO_WM_DIAGRAM_VIRTUALLY_FRAME" val="{&quot;height&quot;:220,&quot;left&quot;:60,&quot;top&quot;:120,&quot;width&quot;:840}"/>
+  <p:tag name="KSO_WM_DIAGRAM_VIRTUALLY_FRAME" val="{&quot;height&quot;:268,&quot;left&quot;:60,&quot;top&quot;:120,&quot;width&quot;:840}"/>
 </p:tagLst>
 </file>
 
 <file path=ppt/tags/tag57.xml><?xml version="1.0" encoding="utf-8"?>
 <p:tagLst xmlns:p="http://schemas.openxmlformats.org/presentationml/2006/main">
-  <p:tag name="KSO_WM_DIAGRAM_VIRTUALLY_FRAME" val="{&quot;height&quot;:220,&quot;left&quot;:60,&quot;top&quot;:120,&quot;width&quot;:840}"/>
+  <p:tag name="KSO_WM_DIAGRAM_VIRTUALLY_FRAME" val="{&quot;height&quot;:268,&quot;left&quot;:60,&quot;top&quot;:120,&quot;width&quot;:840}"/>
 </p:tagLst>
 </file>
 

</xml_diff>

<commit_message>
docs: update Vibe Agentic Coding course PPT
Co-Authored-By: Claude Opus 4.6 <noreply@anthropic.com>
</commit_message>
<xml_diff>
--- a/Tutorial-0/Vibe_Agentic Coding 课程PPT.pptx
+++ b/Tutorial-0/Vibe_Agentic Coding 课程PPT.pptx
@@ -4,17 +4,19 @@
   <p:sldMasterIdLst>
     <p:sldMasterId id="2147483648" r:id="rId1"/>
     <p:sldMasterId id="2147483660" r:id="rId3"/>
+    <p:sldMasterId id="2147483662" r:id="rId4"/>
   </p:sldMasterIdLst>
   <p:notesMasterIdLst>
-    <p:notesMasterId r:id="rId5"/>
+    <p:notesMasterId r:id="rId6"/>
   </p:notesMasterIdLst>
   <p:sldIdLst>
-    <p:sldId id="256" r:id="rId4"/>
-    <p:sldId id="257" r:id="rId6"/>
-    <p:sldId id="258" r:id="rId7"/>
-    <p:sldId id="259" r:id="rId8"/>
-    <p:sldId id="260" r:id="rId9"/>
-    <p:sldId id="261" r:id="rId10"/>
+    <p:sldId id="256" r:id="rId5"/>
+    <p:sldId id="257" r:id="rId7"/>
+    <p:sldId id="258" r:id="rId8"/>
+    <p:sldId id="259" r:id="rId9"/>
+    <p:sldId id="260" r:id="rId10"/>
+    <p:sldId id="261" r:id="rId11"/>
+    <p:sldId id="262" r:id="rId12"/>
   </p:sldIdLst>
   <p:sldSz cx="12192000" cy="6858000"/>
   <p:notesSz cx="6858000" cy="9144000"/>
@@ -2005,6 +2007,238 @@
 </p:notes>
 </file>
 
+<file path=ppt/notesSlides/notesSlide7.xml><?xml version="1.0" encoding="utf-8"?>
+<p:notes xmlns:a="http://schemas.openxmlformats.org/drawingml/2006/main" xmlns:r="http://schemas.openxmlformats.org/officeDocument/2006/relationships" xmlns:p="http://schemas.openxmlformats.org/presentationml/2006/main">
+  <p:cSld>
+    <p:spTree>
+      <p:nvGrpSpPr>
+        <p:cNvPr id="1" name=""/>
+        <p:cNvGrpSpPr/>
+        <p:nvPr/>
+      </p:nvGrpSpPr>
+      <p:grpSpPr>
+        <a:xfrm>
+          <a:off x="0" y="0"/>
+          <a:ext cx="0" cy="0"/>
+          <a:chOff x="0" y="0"/>
+          <a:chExt cx="0" cy="0"/>
+        </a:xfrm>
+      </p:grpSpPr>
+      <p:sp>
+        <p:nvSpPr>
+          <p:cNvPr id="2" name="Header Placeholder 1"/>
+          <p:cNvSpPr>
+            <a:spLocks noGrp="1"/>
+          </p:cNvSpPr>
+          <p:nvPr>
+            <p:ph type="hdr" sz="quarter"/>
+          </p:nvPr>
+        </p:nvSpPr>
+        <p:spPr>
+          <a:xfrm>
+            <a:off x="0" y="0"/>
+            <a:ext cx="3962400" cy="342900"/>
+          </a:xfrm>
+          <a:prstGeom prst="rect">
+            <a:avLst/>
+          </a:prstGeom>
+        </p:spPr>
+        <p:txBody>
+          <a:bodyPr vert="horz" lIns="91440" tIns="45720" rIns="91440" bIns="45720" rtlCol="0"/>
+          <a:lstStyle>
+            <a:lvl1pPr algn="l">
+              <a:defRPr sz="1200"/>
+            </a:lvl1pPr>
+          </a:lstStyle>
+          <a:p/>
+        </p:txBody>
+      </p:sp>
+      <p:sp>
+        <p:nvSpPr>
+          <p:cNvPr id="3" name="Date Placeholder 2"/>
+          <p:cNvSpPr>
+            <a:spLocks noGrp="1"/>
+          </p:cNvSpPr>
+          <p:nvPr>
+            <p:ph type="dt" idx="1"/>
+          </p:nvPr>
+        </p:nvSpPr>
+        <p:spPr>
+          <a:xfrm>
+            <a:off x="5180013" y="0"/>
+            <a:ext cx="3962400" cy="342900"/>
+          </a:xfrm>
+          <a:prstGeom prst="rect">
+            <a:avLst/>
+          </a:prstGeom>
+        </p:spPr>
+        <p:txBody>
+          <a:bodyPr vert="horz" lIns="91440" tIns="45720" rIns="91440" bIns="45720" rtlCol="0"/>
+          <a:lstStyle>
+            <a:lvl1pPr algn="r">
+              <a:defRPr sz="1200"/>
+            </a:lvl1pPr>
+          </a:lstStyle>
+          <a:p>
+            <a:r>
+              <a:rPr lang="cs-CZ" smtClean="0"/>
+              <a:t>1.7.2013</a:t>
+            </a:r>
+            <a:endParaRPr lang="cs-CZ" smtClean="0"/>
+          </a:p>
+        </p:txBody>
+      </p:sp>
+      <p:sp>
+        <p:nvSpPr>
+          <p:cNvPr id="4" name="Slide Image Placeholder 3"/>
+          <p:cNvSpPr>
+            <a:spLocks noGrp="1" noRot="1" noChangeAspect="1"/>
+          </p:cNvSpPr>
+          <p:nvPr>
+            <p:ph type="sldImg" idx="2"/>
+          </p:nvPr>
+        </p:nvSpPr>
+        <p:spPr>
+          <a:xfrm>
+            <a:off x="2857500" y="512763"/>
+            <a:ext cx="3429000" cy="2566987"/>
+          </a:xfrm>
+          <a:prstGeom prst="rect">
+            <a:avLst/>
+          </a:prstGeom>
+          <a:noFill/>
+          <a:ln w="12700">
+            <a:solidFill>
+              <a:prstClr val="black"/>
+            </a:solidFill>
+          </a:ln>
+        </p:spPr>
+        <p:txBody>
+          <a:bodyPr vert="horz" lIns="91440" tIns="45720" rIns="91440" bIns="45720" rtlCol="0" anchor="ctr"/>
+          <a:lstStyle/>
+          <a:p/>
+        </p:txBody>
+      </p:sp>
+      <p:sp>
+        <p:nvSpPr>
+          <p:cNvPr id="5" name="Notes Placeholder 4"/>
+          <p:cNvSpPr>
+            <a:spLocks noGrp="1"/>
+          </p:cNvSpPr>
+          <p:nvPr>
+            <p:ph type="body" sz="quarter" idx="3"/>
+          </p:nvPr>
+        </p:nvSpPr>
+        <p:spPr>
+          <a:xfrm>
+            <a:off x="914400" y="3251200"/>
+            <a:ext cx="7315200" cy="3081338"/>
+          </a:xfrm>
+          <a:prstGeom prst="rect">
+            <a:avLst/>
+          </a:prstGeom>
+        </p:spPr>
+        <p:txBody>
+          <a:bodyPr vert="horz" lIns="91440" tIns="45720" rIns="91440" bIns="45720" rtlCol="0" anchor="ctr"/>
+          <a:lstStyle>
+            <a:lvl1pPr algn="l">
+              <a:defRPr sz="1400" b="0" i="0" u="none" strike="noStrike"/>
+            </a:lvl1pPr>
+          </a:lstStyle>
+          <a:p>
+            <a:pPr indent="0" algn="l">
+              <a:lnSpc>
+                <a:spcPct val="100000"/>
+              </a:lnSpc>
+            </a:pPr>
+            <a:r>
+              <a:rPr lang="en-US" sz="1400" b="0" i="0" u="none" strike="noStrike">
+                <a:solidFill>
+                  <a:srgbClr val="000000"/>
+                </a:solidFill>
+              </a:rPr>
+              <a:t>在课程中，我们将以Unity作为核心的实践载体。为什么选择Unity呢？首先，从行业应用来看，在小团队和独立游戏开发领域，Unity的普及度非常高。其次，从技术门槛考虑，如果选择UE，我们需要额外学习UE的C++，而蓝图又几乎无法与AI结合，这会大大增加学习难度。最后，我们课程的核心内容，除了个别特定功能外，与使用什么引擎关系不大，选择Unity可以让我们更快地聚焦于AI辅助开发本身，降低入门门槛。</a:t>
+            </a:r>
+            <a:endParaRPr lang="en-US" sz="1400" b="0" i="0" u="none" strike="noStrike">
+              <a:solidFill>
+                <a:srgbClr val="000000"/>
+              </a:solidFill>
+            </a:endParaRPr>
+          </a:p>
+        </p:txBody>
+      </p:sp>
+      <p:sp>
+        <p:nvSpPr>
+          <p:cNvPr id="6" name="Footer Placeholder 5"/>
+          <p:cNvSpPr>
+            <a:spLocks noGrp="1"/>
+          </p:cNvSpPr>
+          <p:nvPr>
+            <p:ph type="ftr" sz="quarter" idx="4"/>
+          </p:nvPr>
+        </p:nvSpPr>
+        <p:spPr>
+          <a:xfrm>
+            <a:off x="0" y="6502400"/>
+            <a:ext cx="3962400" cy="341313"/>
+          </a:xfrm>
+          <a:prstGeom prst="rect">
+            <a:avLst/>
+          </a:prstGeom>
+        </p:spPr>
+        <p:txBody>
+          <a:bodyPr vert="horz" lIns="91440" tIns="45720" rIns="91440" bIns="45720" rtlCol="0" anchor="b"/>
+          <a:lstStyle>
+            <a:lvl1pPr algn="l">
+              <a:defRPr sz="1200"/>
+            </a:lvl1pPr>
+          </a:lstStyle>
+          <a:p/>
+        </p:txBody>
+      </p:sp>
+      <p:sp>
+        <p:nvSpPr>
+          <p:cNvPr id="7" name="Slide Number Placeholder 6"/>
+          <p:cNvSpPr>
+            <a:spLocks noGrp="1"/>
+          </p:cNvSpPr>
+          <p:nvPr>
+            <p:ph type="sldNum" sz="quarter" idx="5"/>
+          </p:nvPr>
+        </p:nvSpPr>
+        <p:spPr>
+          <a:xfrm>
+            <a:off x="5180013" y="6502400"/>
+            <a:ext cx="3962400" cy="341313"/>
+          </a:xfrm>
+          <a:prstGeom prst="rect">
+            <a:avLst/>
+          </a:prstGeom>
+        </p:spPr>
+        <p:txBody>
+          <a:bodyPr vert="horz" lIns="91440" tIns="45720" rIns="91440" bIns="45720" rtlCol="0" anchor="b"/>
+          <a:lstStyle>
+            <a:lvl1pPr algn="r">
+              <a:defRPr sz="1200"/>
+            </a:lvl1pPr>
+          </a:lstStyle>
+          <a:p>
+            <a:r>
+              <a:rPr lang="cs-CZ" smtClean="0"/>
+              <a:t>‹#›</a:t>
+            </a:r>
+            <a:endParaRPr lang="cs-CZ" smtClean="0"/>
+          </a:p>
+        </p:txBody>
+      </p:sp>
+    </p:spTree>
+  </p:cSld>
+  <p:clrMapOvr>
+    <a:masterClrMapping/>
+  </p:clrMapOvr>
+</p:notes>
+</file>
+
 <file path=ppt/slideLayouts/slideLayout1.xml><?xml version="1.0" encoding="utf-8"?>
 <p:sldLayout xmlns:a="http://schemas.openxmlformats.org/drawingml/2006/main" xmlns:r="http://schemas.openxmlformats.org/officeDocument/2006/relationships" xmlns:p="http://schemas.openxmlformats.org/presentationml/2006/main" type="title" matchingName="标题幻灯片">
   <p:cSld name="TITLE">
@@ -4131,6 +4365,31 @@
 </file>
 
 <file path=ppt/slideLayouts/slideLayout12.xml><?xml version="1.0" encoding="utf-8"?>
+<p:sldLayout xmlns:a="http://schemas.openxmlformats.org/drawingml/2006/main" xmlns:r="http://schemas.openxmlformats.org/officeDocument/2006/relationships" xmlns:p="http://schemas.openxmlformats.org/presentationml/2006/main" type="title" preserve="1">
+  <p:cSld>
+    <p:spTree>
+      <p:nvGrpSpPr>
+        <p:cNvPr id="1" name=""/>
+        <p:cNvGrpSpPr/>
+        <p:nvPr/>
+      </p:nvGrpSpPr>
+      <p:grpSpPr>
+        <a:xfrm>
+          <a:off x="0" y="0"/>
+          <a:ext cx="0" cy="0"/>
+          <a:chOff x="0" y="0"/>
+          <a:chExt cx="0" cy="0"/>
+        </a:xfrm>
+      </p:grpSpPr>
+    </p:spTree>
+  </p:cSld>
+  <p:clrMapOvr>
+    <a:masterClrMapping/>
+  </p:clrMapOvr>
+</p:sldLayout>
+</file>
+
+<file path=ppt/slideLayouts/slideLayout13.xml><?xml version="1.0" encoding="utf-8"?>
 <p:sldLayout xmlns:a="http://schemas.openxmlformats.org/drawingml/2006/main" xmlns:r="http://schemas.openxmlformats.org/officeDocument/2006/relationships" xmlns:p="http://schemas.openxmlformats.org/presentationml/2006/main" type="title" preserve="1">
   <p:cSld>
     <p:spTree>
@@ -12743,6 +13002,732 @@
 </p:sldMaster>
 </file>
 
+<file path=ppt/slideMasters/slideMaster3.xml><?xml version="1.0" encoding="utf-8"?>
+<p:sldMaster xmlns:a="http://schemas.openxmlformats.org/drawingml/2006/main" xmlns:r="http://schemas.openxmlformats.org/officeDocument/2006/relationships" xmlns:p="http://schemas.openxmlformats.org/presentationml/2006/main">
+  <p:cSld>
+    <p:bg>
+      <p:bgPr>
+        <a:solidFill>
+          <a:srgbClr val="FFFFFF">
+            <a:alpha val="100000"/>
+          </a:srgbClr>
+        </a:solidFill>
+        <a:effectLst/>
+      </p:bgPr>
+    </p:bg>
+    <p:spTree>
+      <p:nvGrpSpPr>
+        <p:cNvPr id="5" name="Shape 5"/>
+        <p:cNvGrpSpPr/>
+        <p:nvPr/>
+      </p:nvGrpSpPr>
+      <p:grpSpPr>
+        <a:xfrm>
+          <a:off x="0" y="0"/>
+          <a:ext cx="0" cy="0"/>
+          <a:chOff x="0" y="0"/>
+          <a:chExt cx="0" cy="0"/>
+        </a:xfrm>
+      </p:grpSpPr>
+    </p:spTree>
+  </p:cSld>
+  <p:clrMap bg1="lt1" tx1="dk1" bg2="dk2" tx2="lt2" accent1="accent1" accent2="accent2" accent3="accent3" accent4="accent4" accent5="accent5" accent6="accent6" hlink="hlink" folHlink="folHlink"/>
+  <p:sldLayoutIdLst>
+    <p:sldLayoutId id="2147483663" r:id="rId1"/>
+  </p:sldLayoutIdLst>
+  <p:hf sldNum="0" hdr="0" ftr="0" dt="0"/>
+  <p:txStyles>
+    <p:titleStyle>
+      <a:defPPr marR="0" lvl="0" algn="l" rtl="0">
+        <a:lnSpc>
+          <a:spcPct val="100000"/>
+        </a:lnSpc>
+        <a:spcBef>
+          <a:spcPts val="0"/>
+        </a:spcBef>
+        <a:spcAft>
+          <a:spcPts val="0"/>
+        </a:spcAft>
+      </a:defPPr>
+      <a:lvl1pPr marR="0" lvl="0" algn="l" rtl="0">
+        <a:lnSpc>
+          <a:spcPct val="100000"/>
+        </a:lnSpc>
+        <a:spcBef>
+          <a:spcPts val="0"/>
+        </a:spcBef>
+        <a:spcAft>
+          <a:spcPts val="0"/>
+        </a:spcAft>
+        <a:buClr>
+          <a:srgbClr val="000000"/>
+        </a:buClr>
+        <a:buFont typeface="Arial" panose="020B0604020202020204"/>
+        <a:defRPr sz="1400" b="0" i="0" u="none" strike="noStrike" cap="none">
+          <a:solidFill>
+            <a:srgbClr val="000000"/>
+          </a:solidFill>
+          <a:latin typeface="Arial" panose="020B0604020202020204"/>
+          <a:ea typeface="Arial" panose="020B0604020202020204"/>
+          <a:cs typeface="Arial" panose="020B0604020202020204"/>
+          <a:sym typeface="Arial" panose="020B0604020202020204"/>
+        </a:defRPr>
+      </a:lvl1pPr>
+      <a:lvl2pPr marR="0" lvl="1" algn="l" rtl="0">
+        <a:lnSpc>
+          <a:spcPct val="100000"/>
+        </a:lnSpc>
+        <a:spcBef>
+          <a:spcPts val="0"/>
+        </a:spcBef>
+        <a:spcAft>
+          <a:spcPts val="0"/>
+        </a:spcAft>
+        <a:buClr>
+          <a:srgbClr val="000000"/>
+        </a:buClr>
+        <a:buFont typeface="Arial" panose="020B0604020202020204"/>
+        <a:defRPr sz="1400" b="0" i="0" u="none" strike="noStrike" cap="none">
+          <a:solidFill>
+            <a:srgbClr val="000000"/>
+          </a:solidFill>
+          <a:latin typeface="Arial" panose="020B0604020202020204"/>
+          <a:ea typeface="Arial" panose="020B0604020202020204"/>
+          <a:cs typeface="Arial" panose="020B0604020202020204"/>
+          <a:sym typeface="Arial" panose="020B0604020202020204"/>
+        </a:defRPr>
+      </a:lvl2pPr>
+      <a:lvl3pPr marR="0" lvl="2" algn="l" rtl="0">
+        <a:lnSpc>
+          <a:spcPct val="100000"/>
+        </a:lnSpc>
+        <a:spcBef>
+          <a:spcPts val="0"/>
+        </a:spcBef>
+        <a:spcAft>
+          <a:spcPts val="0"/>
+        </a:spcAft>
+        <a:buClr>
+          <a:srgbClr val="000000"/>
+        </a:buClr>
+        <a:buFont typeface="Arial" panose="020B0604020202020204"/>
+        <a:defRPr sz="1400" b="0" i="0" u="none" strike="noStrike" cap="none">
+          <a:solidFill>
+            <a:srgbClr val="000000"/>
+          </a:solidFill>
+          <a:latin typeface="Arial" panose="020B0604020202020204"/>
+          <a:ea typeface="Arial" panose="020B0604020202020204"/>
+          <a:cs typeface="Arial" panose="020B0604020202020204"/>
+          <a:sym typeface="Arial" panose="020B0604020202020204"/>
+        </a:defRPr>
+      </a:lvl3pPr>
+      <a:lvl4pPr marR="0" lvl="3" algn="l" rtl="0">
+        <a:lnSpc>
+          <a:spcPct val="100000"/>
+        </a:lnSpc>
+        <a:spcBef>
+          <a:spcPts val="0"/>
+        </a:spcBef>
+        <a:spcAft>
+          <a:spcPts val="0"/>
+        </a:spcAft>
+        <a:buClr>
+          <a:srgbClr val="000000"/>
+        </a:buClr>
+        <a:buFont typeface="Arial" panose="020B0604020202020204"/>
+        <a:defRPr sz="1400" b="0" i="0" u="none" strike="noStrike" cap="none">
+          <a:solidFill>
+            <a:srgbClr val="000000"/>
+          </a:solidFill>
+          <a:latin typeface="Arial" panose="020B0604020202020204"/>
+          <a:ea typeface="Arial" panose="020B0604020202020204"/>
+          <a:cs typeface="Arial" panose="020B0604020202020204"/>
+          <a:sym typeface="Arial" panose="020B0604020202020204"/>
+        </a:defRPr>
+      </a:lvl4pPr>
+      <a:lvl5pPr marR="0" lvl="4" algn="l" rtl="0">
+        <a:lnSpc>
+          <a:spcPct val="100000"/>
+        </a:lnSpc>
+        <a:spcBef>
+          <a:spcPts val="0"/>
+        </a:spcBef>
+        <a:spcAft>
+          <a:spcPts val="0"/>
+        </a:spcAft>
+        <a:buClr>
+          <a:srgbClr val="000000"/>
+        </a:buClr>
+        <a:buFont typeface="Arial" panose="020B0604020202020204"/>
+        <a:defRPr sz="1400" b="0" i="0" u="none" strike="noStrike" cap="none">
+          <a:solidFill>
+            <a:srgbClr val="000000"/>
+          </a:solidFill>
+          <a:latin typeface="Arial" panose="020B0604020202020204"/>
+          <a:ea typeface="Arial" panose="020B0604020202020204"/>
+          <a:cs typeface="Arial" panose="020B0604020202020204"/>
+          <a:sym typeface="Arial" panose="020B0604020202020204"/>
+        </a:defRPr>
+      </a:lvl5pPr>
+      <a:lvl6pPr marR="0" lvl="5" algn="l" rtl="0">
+        <a:lnSpc>
+          <a:spcPct val="100000"/>
+        </a:lnSpc>
+        <a:spcBef>
+          <a:spcPts val="0"/>
+        </a:spcBef>
+        <a:spcAft>
+          <a:spcPts val="0"/>
+        </a:spcAft>
+        <a:buClr>
+          <a:srgbClr val="000000"/>
+        </a:buClr>
+        <a:buFont typeface="Arial" panose="020B0604020202020204"/>
+        <a:defRPr sz="1400" b="0" i="0" u="none" strike="noStrike" cap="none">
+          <a:solidFill>
+            <a:srgbClr val="000000"/>
+          </a:solidFill>
+          <a:latin typeface="Arial" panose="020B0604020202020204"/>
+          <a:ea typeface="Arial" panose="020B0604020202020204"/>
+          <a:cs typeface="Arial" panose="020B0604020202020204"/>
+          <a:sym typeface="Arial" panose="020B0604020202020204"/>
+        </a:defRPr>
+      </a:lvl6pPr>
+      <a:lvl7pPr marR="0" lvl="6" algn="l" rtl="0">
+        <a:lnSpc>
+          <a:spcPct val="100000"/>
+        </a:lnSpc>
+        <a:spcBef>
+          <a:spcPts val="0"/>
+        </a:spcBef>
+        <a:spcAft>
+          <a:spcPts val="0"/>
+        </a:spcAft>
+        <a:buClr>
+          <a:srgbClr val="000000"/>
+        </a:buClr>
+        <a:buFont typeface="Arial" panose="020B0604020202020204"/>
+        <a:defRPr sz="1400" b="0" i="0" u="none" strike="noStrike" cap="none">
+          <a:solidFill>
+            <a:srgbClr val="000000"/>
+          </a:solidFill>
+          <a:latin typeface="Arial" panose="020B0604020202020204"/>
+          <a:ea typeface="Arial" panose="020B0604020202020204"/>
+          <a:cs typeface="Arial" panose="020B0604020202020204"/>
+          <a:sym typeface="Arial" panose="020B0604020202020204"/>
+        </a:defRPr>
+      </a:lvl7pPr>
+      <a:lvl8pPr marR="0" lvl="7" algn="l" rtl="0">
+        <a:lnSpc>
+          <a:spcPct val="100000"/>
+        </a:lnSpc>
+        <a:spcBef>
+          <a:spcPts val="0"/>
+        </a:spcBef>
+        <a:spcAft>
+          <a:spcPts val="0"/>
+        </a:spcAft>
+        <a:buClr>
+          <a:srgbClr val="000000"/>
+        </a:buClr>
+        <a:buFont typeface="Arial" panose="020B0604020202020204"/>
+        <a:defRPr sz="1400" b="0" i="0" u="none" strike="noStrike" cap="none">
+          <a:solidFill>
+            <a:srgbClr val="000000"/>
+          </a:solidFill>
+          <a:latin typeface="Arial" panose="020B0604020202020204"/>
+          <a:ea typeface="Arial" panose="020B0604020202020204"/>
+          <a:cs typeface="Arial" panose="020B0604020202020204"/>
+          <a:sym typeface="Arial" panose="020B0604020202020204"/>
+        </a:defRPr>
+      </a:lvl8pPr>
+      <a:lvl9pPr marR="0" lvl="8" algn="l" rtl="0">
+        <a:lnSpc>
+          <a:spcPct val="100000"/>
+        </a:lnSpc>
+        <a:spcBef>
+          <a:spcPts val="0"/>
+        </a:spcBef>
+        <a:spcAft>
+          <a:spcPts val="0"/>
+        </a:spcAft>
+        <a:buClr>
+          <a:srgbClr val="000000"/>
+        </a:buClr>
+        <a:buFont typeface="Arial" panose="020B0604020202020204"/>
+        <a:defRPr sz="1400" b="0" i="0" u="none" strike="noStrike" cap="none">
+          <a:solidFill>
+            <a:srgbClr val="000000"/>
+          </a:solidFill>
+          <a:latin typeface="Arial" panose="020B0604020202020204"/>
+          <a:ea typeface="Arial" panose="020B0604020202020204"/>
+          <a:cs typeface="Arial" panose="020B0604020202020204"/>
+          <a:sym typeface="Arial" panose="020B0604020202020204"/>
+        </a:defRPr>
+      </a:lvl9pPr>
+    </p:titleStyle>
+    <p:bodyStyle>
+      <a:defPPr marR="0" lvl="0" algn="l" rtl="0">
+        <a:lnSpc>
+          <a:spcPct val="100000"/>
+        </a:lnSpc>
+        <a:spcBef>
+          <a:spcPts val="0"/>
+        </a:spcBef>
+        <a:spcAft>
+          <a:spcPts val="0"/>
+        </a:spcAft>
+      </a:defPPr>
+      <a:lvl1pPr marR="0" lvl="0" algn="l" rtl="0">
+        <a:lnSpc>
+          <a:spcPct val="100000"/>
+        </a:lnSpc>
+        <a:spcBef>
+          <a:spcPts val="0"/>
+        </a:spcBef>
+        <a:spcAft>
+          <a:spcPts val="0"/>
+        </a:spcAft>
+        <a:buClr>
+          <a:srgbClr val="000000"/>
+        </a:buClr>
+        <a:buFont typeface="Arial" panose="020B0604020202020204"/>
+        <a:defRPr sz="1400" b="0" i="0" u="none" strike="noStrike" cap="none">
+          <a:solidFill>
+            <a:srgbClr val="000000"/>
+          </a:solidFill>
+          <a:latin typeface="Arial" panose="020B0604020202020204"/>
+          <a:ea typeface="Arial" panose="020B0604020202020204"/>
+          <a:cs typeface="Arial" panose="020B0604020202020204"/>
+          <a:sym typeface="Arial" panose="020B0604020202020204"/>
+        </a:defRPr>
+      </a:lvl1pPr>
+      <a:lvl2pPr marR="0" lvl="1" algn="l" rtl="0">
+        <a:lnSpc>
+          <a:spcPct val="100000"/>
+        </a:lnSpc>
+        <a:spcBef>
+          <a:spcPts val="0"/>
+        </a:spcBef>
+        <a:spcAft>
+          <a:spcPts val="0"/>
+        </a:spcAft>
+        <a:buClr>
+          <a:srgbClr val="000000"/>
+        </a:buClr>
+        <a:buFont typeface="Arial" panose="020B0604020202020204"/>
+        <a:defRPr sz="1400" b="0" i="0" u="none" strike="noStrike" cap="none">
+          <a:solidFill>
+            <a:srgbClr val="000000"/>
+          </a:solidFill>
+          <a:latin typeface="Arial" panose="020B0604020202020204"/>
+          <a:ea typeface="Arial" panose="020B0604020202020204"/>
+          <a:cs typeface="Arial" panose="020B0604020202020204"/>
+          <a:sym typeface="Arial" panose="020B0604020202020204"/>
+        </a:defRPr>
+      </a:lvl2pPr>
+      <a:lvl3pPr marR="0" lvl="2" algn="l" rtl="0">
+        <a:lnSpc>
+          <a:spcPct val="100000"/>
+        </a:lnSpc>
+        <a:spcBef>
+          <a:spcPts val="0"/>
+        </a:spcBef>
+        <a:spcAft>
+          <a:spcPts val="0"/>
+        </a:spcAft>
+        <a:buClr>
+          <a:srgbClr val="000000"/>
+        </a:buClr>
+        <a:buFont typeface="Arial" panose="020B0604020202020204"/>
+        <a:defRPr sz="1400" b="0" i="0" u="none" strike="noStrike" cap="none">
+          <a:solidFill>
+            <a:srgbClr val="000000"/>
+          </a:solidFill>
+          <a:latin typeface="Arial" panose="020B0604020202020204"/>
+          <a:ea typeface="Arial" panose="020B0604020202020204"/>
+          <a:cs typeface="Arial" panose="020B0604020202020204"/>
+          <a:sym typeface="Arial" panose="020B0604020202020204"/>
+        </a:defRPr>
+      </a:lvl3pPr>
+      <a:lvl4pPr marR="0" lvl="3" algn="l" rtl="0">
+        <a:lnSpc>
+          <a:spcPct val="100000"/>
+        </a:lnSpc>
+        <a:spcBef>
+          <a:spcPts val="0"/>
+        </a:spcBef>
+        <a:spcAft>
+          <a:spcPts val="0"/>
+        </a:spcAft>
+        <a:buClr>
+          <a:srgbClr val="000000"/>
+        </a:buClr>
+        <a:buFont typeface="Arial" panose="020B0604020202020204"/>
+        <a:defRPr sz="1400" b="0" i="0" u="none" strike="noStrike" cap="none">
+          <a:solidFill>
+            <a:srgbClr val="000000"/>
+          </a:solidFill>
+          <a:latin typeface="Arial" panose="020B0604020202020204"/>
+          <a:ea typeface="Arial" panose="020B0604020202020204"/>
+          <a:cs typeface="Arial" panose="020B0604020202020204"/>
+          <a:sym typeface="Arial" panose="020B0604020202020204"/>
+        </a:defRPr>
+      </a:lvl4pPr>
+      <a:lvl5pPr marR="0" lvl="4" algn="l" rtl="0">
+        <a:lnSpc>
+          <a:spcPct val="100000"/>
+        </a:lnSpc>
+        <a:spcBef>
+          <a:spcPts val="0"/>
+        </a:spcBef>
+        <a:spcAft>
+          <a:spcPts val="0"/>
+        </a:spcAft>
+        <a:buClr>
+          <a:srgbClr val="000000"/>
+        </a:buClr>
+        <a:buFont typeface="Arial" panose="020B0604020202020204"/>
+        <a:defRPr sz="1400" b="0" i="0" u="none" strike="noStrike" cap="none">
+          <a:solidFill>
+            <a:srgbClr val="000000"/>
+          </a:solidFill>
+          <a:latin typeface="Arial" panose="020B0604020202020204"/>
+          <a:ea typeface="Arial" panose="020B0604020202020204"/>
+          <a:cs typeface="Arial" panose="020B0604020202020204"/>
+          <a:sym typeface="Arial" panose="020B0604020202020204"/>
+        </a:defRPr>
+      </a:lvl5pPr>
+      <a:lvl6pPr marR="0" lvl="5" algn="l" rtl="0">
+        <a:lnSpc>
+          <a:spcPct val="100000"/>
+        </a:lnSpc>
+        <a:spcBef>
+          <a:spcPts val="0"/>
+        </a:spcBef>
+        <a:spcAft>
+          <a:spcPts val="0"/>
+        </a:spcAft>
+        <a:buClr>
+          <a:srgbClr val="000000"/>
+        </a:buClr>
+        <a:buFont typeface="Arial" panose="020B0604020202020204"/>
+        <a:defRPr sz="1400" b="0" i="0" u="none" strike="noStrike" cap="none">
+          <a:solidFill>
+            <a:srgbClr val="000000"/>
+          </a:solidFill>
+          <a:latin typeface="Arial" panose="020B0604020202020204"/>
+          <a:ea typeface="Arial" panose="020B0604020202020204"/>
+          <a:cs typeface="Arial" panose="020B0604020202020204"/>
+          <a:sym typeface="Arial" panose="020B0604020202020204"/>
+        </a:defRPr>
+      </a:lvl6pPr>
+      <a:lvl7pPr marR="0" lvl="6" algn="l" rtl="0">
+        <a:lnSpc>
+          <a:spcPct val="100000"/>
+        </a:lnSpc>
+        <a:spcBef>
+          <a:spcPts val="0"/>
+        </a:spcBef>
+        <a:spcAft>
+          <a:spcPts val="0"/>
+        </a:spcAft>
+        <a:buClr>
+          <a:srgbClr val="000000"/>
+        </a:buClr>
+        <a:buFont typeface="Arial" panose="020B0604020202020204"/>
+        <a:defRPr sz="1400" b="0" i="0" u="none" strike="noStrike" cap="none">
+          <a:solidFill>
+            <a:srgbClr val="000000"/>
+          </a:solidFill>
+          <a:latin typeface="Arial" panose="020B0604020202020204"/>
+          <a:ea typeface="Arial" panose="020B0604020202020204"/>
+          <a:cs typeface="Arial" panose="020B0604020202020204"/>
+          <a:sym typeface="Arial" panose="020B0604020202020204"/>
+        </a:defRPr>
+      </a:lvl7pPr>
+      <a:lvl8pPr marR="0" lvl="7" algn="l" rtl="0">
+        <a:lnSpc>
+          <a:spcPct val="100000"/>
+        </a:lnSpc>
+        <a:spcBef>
+          <a:spcPts val="0"/>
+        </a:spcBef>
+        <a:spcAft>
+          <a:spcPts val="0"/>
+        </a:spcAft>
+        <a:buClr>
+          <a:srgbClr val="000000"/>
+        </a:buClr>
+        <a:buFont typeface="Arial" panose="020B0604020202020204"/>
+        <a:defRPr sz="1400" b="0" i="0" u="none" strike="noStrike" cap="none">
+          <a:solidFill>
+            <a:srgbClr val="000000"/>
+          </a:solidFill>
+          <a:latin typeface="Arial" panose="020B0604020202020204"/>
+          <a:ea typeface="Arial" panose="020B0604020202020204"/>
+          <a:cs typeface="Arial" panose="020B0604020202020204"/>
+          <a:sym typeface="Arial" panose="020B0604020202020204"/>
+        </a:defRPr>
+      </a:lvl8pPr>
+      <a:lvl9pPr marR="0" lvl="8" algn="l" rtl="0">
+        <a:lnSpc>
+          <a:spcPct val="100000"/>
+        </a:lnSpc>
+        <a:spcBef>
+          <a:spcPts val="0"/>
+        </a:spcBef>
+        <a:spcAft>
+          <a:spcPts val="0"/>
+        </a:spcAft>
+        <a:buClr>
+          <a:srgbClr val="000000"/>
+        </a:buClr>
+        <a:buFont typeface="Arial" panose="020B0604020202020204"/>
+        <a:defRPr sz="1400" b="0" i="0" u="none" strike="noStrike" cap="none">
+          <a:solidFill>
+            <a:srgbClr val="000000"/>
+          </a:solidFill>
+          <a:latin typeface="Arial" panose="020B0604020202020204"/>
+          <a:ea typeface="Arial" panose="020B0604020202020204"/>
+          <a:cs typeface="Arial" panose="020B0604020202020204"/>
+          <a:sym typeface="Arial" panose="020B0604020202020204"/>
+        </a:defRPr>
+      </a:lvl9pPr>
+    </p:bodyStyle>
+    <p:otherStyle>
+      <a:defPPr marR="0" lvl="0" algn="l" rtl="0">
+        <a:lnSpc>
+          <a:spcPct val="100000"/>
+        </a:lnSpc>
+        <a:spcBef>
+          <a:spcPts val="0"/>
+        </a:spcBef>
+        <a:spcAft>
+          <a:spcPts val="0"/>
+        </a:spcAft>
+      </a:defPPr>
+      <a:lvl1pPr marR="0" lvl="0" algn="l" rtl="0">
+        <a:lnSpc>
+          <a:spcPct val="100000"/>
+        </a:lnSpc>
+        <a:spcBef>
+          <a:spcPts val="0"/>
+        </a:spcBef>
+        <a:spcAft>
+          <a:spcPts val="0"/>
+        </a:spcAft>
+        <a:buClr>
+          <a:srgbClr val="000000"/>
+        </a:buClr>
+        <a:buFont typeface="Arial" panose="020B0604020202020204"/>
+        <a:defRPr sz="1400" b="0" i="0" u="none" strike="noStrike" cap="none">
+          <a:solidFill>
+            <a:srgbClr val="000000"/>
+          </a:solidFill>
+          <a:latin typeface="Arial" panose="020B0604020202020204"/>
+          <a:ea typeface="Arial" panose="020B0604020202020204"/>
+          <a:cs typeface="Arial" panose="020B0604020202020204"/>
+          <a:sym typeface="Arial" panose="020B0604020202020204"/>
+        </a:defRPr>
+      </a:lvl1pPr>
+      <a:lvl2pPr marR="0" lvl="1" algn="l" rtl="0">
+        <a:lnSpc>
+          <a:spcPct val="100000"/>
+        </a:lnSpc>
+        <a:spcBef>
+          <a:spcPts val="0"/>
+        </a:spcBef>
+        <a:spcAft>
+          <a:spcPts val="0"/>
+        </a:spcAft>
+        <a:buClr>
+          <a:srgbClr val="000000"/>
+        </a:buClr>
+        <a:buFont typeface="Arial" panose="020B0604020202020204"/>
+        <a:defRPr sz="1400" b="0" i="0" u="none" strike="noStrike" cap="none">
+          <a:solidFill>
+            <a:srgbClr val="000000"/>
+          </a:solidFill>
+          <a:latin typeface="Arial" panose="020B0604020202020204"/>
+          <a:ea typeface="Arial" panose="020B0604020202020204"/>
+          <a:cs typeface="Arial" panose="020B0604020202020204"/>
+          <a:sym typeface="Arial" panose="020B0604020202020204"/>
+        </a:defRPr>
+      </a:lvl2pPr>
+      <a:lvl3pPr marR="0" lvl="2" algn="l" rtl="0">
+        <a:lnSpc>
+          <a:spcPct val="100000"/>
+        </a:lnSpc>
+        <a:spcBef>
+          <a:spcPts val="0"/>
+        </a:spcBef>
+        <a:spcAft>
+          <a:spcPts val="0"/>
+        </a:spcAft>
+        <a:buClr>
+          <a:srgbClr val="000000"/>
+        </a:buClr>
+        <a:buFont typeface="Arial" panose="020B0604020202020204"/>
+        <a:defRPr sz="1400" b="0" i="0" u="none" strike="noStrike" cap="none">
+          <a:solidFill>
+            <a:srgbClr val="000000"/>
+          </a:solidFill>
+          <a:latin typeface="Arial" panose="020B0604020202020204"/>
+          <a:ea typeface="Arial" panose="020B0604020202020204"/>
+          <a:cs typeface="Arial" panose="020B0604020202020204"/>
+          <a:sym typeface="Arial" panose="020B0604020202020204"/>
+        </a:defRPr>
+      </a:lvl3pPr>
+      <a:lvl4pPr marR="0" lvl="3" algn="l" rtl="0">
+        <a:lnSpc>
+          <a:spcPct val="100000"/>
+        </a:lnSpc>
+        <a:spcBef>
+          <a:spcPts val="0"/>
+        </a:spcBef>
+        <a:spcAft>
+          <a:spcPts val="0"/>
+        </a:spcAft>
+        <a:buClr>
+          <a:srgbClr val="000000"/>
+        </a:buClr>
+        <a:buFont typeface="Arial" panose="020B0604020202020204"/>
+        <a:defRPr sz="1400" b="0" i="0" u="none" strike="noStrike" cap="none">
+          <a:solidFill>
+            <a:srgbClr val="000000"/>
+          </a:solidFill>
+          <a:latin typeface="Arial" panose="020B0604020202020204"/>
+          <a:ea typeface="Arial" panose="020B0604020202020204"/>
+          <a:cs typeface="Arial" panose="020B0604020202020204"/>
+          <a:sym typeface="Arial" panose="020B0604020202020204"/>
+        </a:defRPr>
+      </a:lvl4pPr>
+      <a:lvl5pPr marR="0" lvl="4" algn="l" rtl="0">
+        <a:lnSpc>
+          <a:spcPct val="100000"/>
+        </a:lnSpc>
+        <a:spcBef>
+          <a:spcPts val="0"/>
+        </a:spcBef>
+        <a:spcAft>
+          <a:spcPts val="0"/>
+        </a:spcAft>
+        <a:buClr>
+          <a:srgbClr val="000000"/>
+        </a:buClr>
+        <a:buFont typeface="Arial" panose="020B0604020202020204"/>
+        <a:defRPr sz="1400" b="0" i="0" u="none" strike="noStrike" cap="none">
+          <a:solidFill>
+            <a:srgbClr val="000000"/>
+          </a:solidFill>
+          <a:latin typeface="Arial" panose="020B0604020202020204"/>
+          <a:ea typeface="Arial" panose="020B0604020202020204"/>
+          <a:cs typeface="Arial" panose="020B0604020202020204"/>
+          <a:sym typeface="Arial" panose="020B0604020202020204"/>
+        </a:defRPr>
+      </a:lvl5pPr>
+      <a:lvl6pPr marR="0" lvl="5" algn="l" rtl="0">
+        <a:lnSpc>
+          <a:spcPct val="100000"/>
+        </a:lnSpc>
+        <a:spcBef>
+          <a:spcPts val="0"/>
+        </a:spcBef>
+        <a:spcAft>
+          <a:spcPts val="0"/>
+        </a:spcAft>
+        <a:buClr>
+          <a:srgbClr val="000000"/>
+        </a:buClr>
+        <a:buFont typeface="Arial" panose="020B0604020202020204"/>
+        <a:defRPr sz="1400" b="0" i="0" u="none" strike="noStrike" cap="none">
+          <a:solidFill>
+            <a:srgbClr val="000000"/>
+          </a:solidFill>
+          <a:latin typeface="Arial" panose="020B0604020202020204"/>
+          <a:ea typeface="Arial" panose="020B0604020202020204"/>
+          <a:cs typeface="Arial" panose="020B0604020202020204"/>
+          <a:sym typeface="Arial" panose="020B0604020202020204"/>
+        </a:defRPr>
+      </a:lvl6pPr>
+      <a:lvl7pPr marR="0" lvl="6" algn="l" rtl="0">
+        <a:lnSpc>
+          <a:spcPct val="100000"/>
+        </a:lnSpc>
+        <a:spcBef>
+          <a:spcPts val="0"/>
+        </a:spcBef>
+        <a:spcAft>
+          <a:spcPts val="0"/>
+        </a:spcAft>
+        <a:buClr>
+          <a:srgbClr val="000000"/>
+        </a:buClr>
+        <a:buFont typeface="Arial" panose="020B0604020202020204"/>
+        <a:defRPr sz="1400" b="0" i="0" u="none" strike="noStrike" cap="none">
+          <a:solidFill>
+            <a:srgbClr val="000000"/>
+          </a:solidFill>
+          <a:latin typeface="Arial" panose="020B0604020202020204"/>
+          <a:ea typeface="Arial" panose="020B0604020202020204"/>
+          <a:cs typeface="Arial" panose="020B0604020202020204"/>
+          <a:sym typeface="Arial" panose="020B0604020202020204"/>
+        </a:defRPr>
+      </a:lvl7pPr>
+      <a:lvl8pPr marR="0" lvl="7" algn="l" rtl="0">
+        <a:lnSpc>
+          <a:spcPct val="100000"/>
+        </a:lnSpc>
+        <a:spcBef>
+          <a:spcPts val="0"/>
+        </a:spcBef>
+        <a:spcAft>
+          <a:spcPts val="0"/>
+        </a:spcAft>
+        <a:buClr>
+          <a:srgbClr val="000000"/>
+        </a:buClr>
+        <a:buFont typeface="Arial" panose="020B0604020202020204"/>
+        <a:defRPr sz="1400" b="0" i="0" u="none" strike="noStrike" cap="none">
+          <a:solidFill>
+            <a:srgbClr val="000000"/>
+          </a:solidFill>
+          <a:latin typeface="Arial" panose="020B0604020202020204"/>
+          <a:ea typeface="Arial" panose="020B0604020202020204"/>
+          <a:cs typeface="Arial" panose="020B0604020202020204"/>
+          <a:sym typeface="Arial" panose="020B0604020202020204"/>
+        </a:defRPr>
+      </a:lvl8pPr>
+      <a:lvl9pPr marR="0" lvl="8" algn="l" rtl="0">
+        <a:lnSpc>
+          <a:spcPct val="100000"/>
+        </a:lnSpc>
+        <a:spcBef>
+          <a:spcPts val="0"/>
+        </a:spcBef>
+        <a:spcAft>
+          <a:spcPts val="0"/>
+        </a:spcAft>
+        <a:buClr>
+          <a:srgbClr val="000000"/>
+        </a:buClr>
+        <a:buFont typeface="Arial" panose="020B0604020202020204"/>
+        <a:defRPr sz="1400" b="0" i="0" u="none" strike="noStrike" cap="none">
+          <a:solidFill>
+            <a:srgbClr val="000000"/>
+          </a:solidFill>
+          <a:latin typeface="Arial" panose="020B0604020202020204"/>
+          <a:ea typeface="Arial" panose="020B0604020202020204"/>
+          <a:cs typeface="Arial" panose="020B0604020202020204"/>
+          <a:sym typeface="Arial" panose="020B0604020202020204"/>
+        </a:defRPr>
+      </a:lvl9pPr>
+    </p:otherStyle>
+  </p:txStyles>
+</p:sldMaster>
+</file>
+
 <file path=ppt/slides/slide1.xml><?xml version="1.0" encoding="utf-8"?>
 <p:sld xmlns:a="http://schemas.openxmlformats.org/drawingml/2006/main" xmlns:r="http://schemas.openxmlformats.org/officeDocument/2006/relationships" xmlns:p="http://schemas.openxmlformats.org/presentationml/2006/main">
   <p:cSld>
@@ -12854,7 +13839,31 @@
                 <a:cs typeface="Noto Sans SC" panose="020B0200000000000000" charset="-122"/>
                 <a:sym typeface="Noto Sans SC" panose="020B0200000000000000" charset="-122"/>
               </a:rPr>
-              <a:t>Vibe/Agentic Coding 入门</a:t>
+              <a:t>AI</a:t>
+            </a:r>
+            <a:r>
+              <a:rPr lang="zh-CN" altLang="en-US" sz="3200" b="1" i="0" u="none" strike="noStrike">
+                <a:solidFill>
+                  <a:srgbClr val="FFFFFF"/>
+                </a:solidFill>
+                <a:latin typeface="Noto Sans SC" panose="020B0200000000000000" charset="-122"/>
+                <a:ea typeface="Noto Sans SC" panose="020B0200000000000000" charset="-122"/>
+                <a:cs typeface="Noto Sans SC" panose="020B0200000000000000" charset="-122"/>
+                <a:sym typeface="Noto Sans SC" panose="020B0200000000000000" charset="-122"/>
+              </a:rPr>
+              <a:t>编程</a:t>
+            </a:r>
+            <a:r>
+              <a:rPr lang="en-US" sz="3200" b="1" i="0" u="none" strike="noStrike">
+                <a:solidFill>
+                  <a:srgbClr val="FFFFFF"/>
+                </a:solidFill>
+                <a:latin typeface="Noto Sans SC" panose="020B0200000000000000" charset="-122"/>
+                <a:ea typeface="Noto Sans SC" panose="020B0200000000000000" charset="-122"/>
+                <a:cs typeface="Noto Sans SC" panose="020B0200000000000000" charset="-122"/>
+                <a:sym typeface="Noto Sans SC" panose="020B0200000000000000" charset="-122"/>
+              </a:rPr>
+              <a:t>入门</a:t>
             </a:r>
             <a:endParaRPr lang="en-US" sz="1100"/>
           </a:p>
@@ -13136,7 +14145,31 @@
                 <a:cs typeface="Noto Sans SC" panose="020B0200000000000000" charset="-122"/>
                 <a:sym typeface="Noto Sans SC" panose="020B0200000000000000" charset="-122"/>
               </a:rPr>
-              <a:t>为什么学Vibe/Agentic Coding？</a:t>
+              <a:t>为什么学AI</a:t>
+            </a:r>
+            <a:r>
+              <a:rPr lang="zh-CN" altLang="en-US" sz="2400" b="1" i="0" u="none" strike="noStrike">
+                <a:solidFill>
+                  <a:srgbClr val="000000"/>
+                </a:solidFill>
+                <a:latin typeface="Noto Sans SC" panose="020B0200000000000000" charset="-122"/>
+                <a:ea typeface="Noto Sans SC" panose="020B0200000000000000" charset="-122"/>
+                <a:cs typeface="Noto Sans SC" panose="020B0200000000000000" charset="-122"/>
+                <a:sym typeface="Noto Sans SC" panose="020B0200000000000000" charset="-122"/>
+              </a:rPr>
+              <a:t>编程</a:t>
+            </a:r>
+            <a:r>
+              <a:rPr lang="en-US" sz="2400" b="1" i="0" u="none" strike="noStrike">
+                <a:solidFill>
+                  <a:srgbClr val="000000"/>
+                </a:solidFill>
+                <a:latin typeface="Noto Sans SC" panose="020B0200000000000000" charset="-122"/>
+                <a:ea typeface="Noto Sans SC" panose="020B0200000000000000" charset="-122"/>
+                <a:cs typeface="Noto Sans SC" panose="020B0200000000000000" charset="-122"/>
+                <a:sym typeface="Noto Sans SC" panose="020B0200000000000000" charset="-122"/>
+              </a:rPr>
+              <a:t>？</a:t>
             </a:r>
             <a:endParaRPr lang="en-US" sz="1100"/>
           </a:p>
@@ -14403,7 +15436,10 @@
               <a:t>第二周： </a:t>
             </a:r>
             <a:r>
-              <a:rPr lang="zh-CN" altLang="en-US" sz="1600" b="1">
+              <a:rPr lang="zh-CN" altLang="en-US" sz="1600" b="1" i="0" u="none" strike="noStrike">
+                <a:solidFill>
+                  <a:srgbClr val="000000"/>
+                </a:solidFill>
                 <a:latin typeface="Noto Sans SC" panose="020B0200000000000000" charset="-122"/>
                 <a:ea typeface="Noto Sans SC" panose="020B0200000000000000" charset="-122"/>
                 <a:cs typeface="Noto Sans SC" panose="020B0200000000000000" charset="-122"/>
@@ -14412,7 +15448,10 @@
               <a:t>子代理</a:t>
             </a:r>
             <a:r>
-              <a:rPr lang="en-US" altLang="zh-CN" sz="1600" b="1">
+              <a:rPr lang="en-US" altLang="zh-CN" sz="1600" b="1" i="0" u="none" strike="noStrike">
+                <a:solidFill>
+                  <a:srgbClr val="000000"/>
+                </a:solidFill>
                 <a:latin typeface="Noto Sans SC" panose="020B0200000000000000" charset="-122"/>
                 <a:ea typeface="Noto Sans SC" panose="020B0200000000000000" charset="-122"/>
                 <a:cs typeface="Noto Sans SC" panose="020B0200000000000000" charset="-122"/>
@@ -17954,6 +18993,175 @@
               <a:cs typeface="Noto Sans SC" panose="020B0200000000000000" charset="-122"/>
               <a:sym typeface="Noto Sans SC" panose="020B0200000000000000" charset="-122"/>
             </a:endParaRPr>
+          </a:p>
+        </p:txBody>
+      </p:sp>
+    </p:spTree>
+  </p:cSld>
+  <p:clrMapOvr>
+    <a:masterClrMapping/>
+  </p:clrMapOvr>
+</p:sld>
+</file>
+
+<file path=ppt/slides/slide7.xml><?xml version="1.0" encoding="utf-8"?>
+<p:sld xmlns:a="http://schemas.openxmlformats.org/drawingml/2006/main" xmlns:r="http://schemas.openxmlformats.org/officeDocument/2006/relationships" xmlns:p="http://schemas.openxmlformats.org/presentationml/2006/main">
+  <p:cSld>
+    <p:bg>
+      <p:bgPr>
+        <a:solidFill>
+          <a:srgbClr val="F5F7FA">
+            <a:alpha val="100000"/>
+          </a:srgbClr>
+        </a:solidFill>
+        <a:effectLst/>
+      </p:bgPr>
+    </p:bg>
+    <p:spTree>
+      <p:nvGrpSpPr>
+        <p:cNvPr id="1" name=""/>
+        <p:cNvGrpSpPr/>
+        <p:nvPr/>
+      </p:nvGrpSpPr>
+      <p:grpSpPr>
+        <a:xfrm>
+          <a:off x="0" y="0"/>
+          <a:ext cx="0" cy="0"/>
+          <a:chOff x="0" y="0"/>
+          <a:chExt cx="0" cy="0"/>
+        </a:xfrm>
+      </p:grpSpPr>
+      <p:sp>
+        <p:nvSpPr>
+          <p:cNvPr id="2" name="AutoShape 2"/>
+          <p:cNvSpPr/>
+          <p:nvPr/>
+        </p:nvSpPr>
+        <p:spPr>
+          <a:xfrm>
+            <a:off x="762000" y="635000"/>
+            <a:ext cx="5702300" cy="508000"/>
+          </a:xfrm>
+          <a:prstGeom prst="rect">
+            <a:avLst/>
+          </a:prstGeom>
+          <a:noFill/>
+          <a:ln w="12700" cap="flat" cmpd="sng">
+            <a:noFill/>
+            <a:prstDash val="solid"/>
+            <a:round/>
+          </a:ln>
+        </p:spPr>
+        <p:txBody>
+          <a:bodyPr vert="horz" wrap="none" lIns="0" tIns="0" rIns="0" bIns="0" rtlCol="0" anchor="ctr" anchorCtr="0"/>
+          <a:lstStyle/>
+          <a:p>
+            <a:pPr indent="0" algn="l">
+              <a:lnSpc>
+                <a:spcPct val="125000"/>
+              </a:lnSpc>
+              <a:defRPr/>
+            </a:pPr>
+            <a:r>
+              <a:rPr lang="zh-CN" altLang="en-US" sz="2400" b="1" i="0" u="none" strike="noStrike">
+                <a:solidFill>
+                  <a:srgbClr val="000000"/>
+                </a:solidFill>
+                <a:latin typeface="Noto Sans SC" panose="020B0200000000000000" charset="-122"/>
+                <a:ea typeface="Noto Sans SC" panose="020B0200000000000000" charset="-122"/>
+                <a:cs typeface="Noto Sans SC" panose="020B0200000000000000" charset="-122"/>
+                <a:sym typeface="Noto Sans SC" panose="020B0200000000000000" charset="-122"/>
+              </a:rPr>
+              <a:t>内容基于</a:t>
+            </a:r>
+            <a:r>
+              <a:rPr lang="en-US" altLang="zh-CN" sz="2400" b="1" i="0" u="none" strike="noStrike">
+                <a:solidFill>
+                  <a:srgbClr val="000000"/>
+                </a:solidFill>
+                <a:latin typeface="Noto Sans SC" panose="020B0200000000000000" charset="-122"/>
+                <a:ea typeface="Noto Sans SC" panose="020B0200000000000000" charset="-122"/>
+                <a:cs typeface="Noto Sans SC" panose="020B0200000000000000" charset="-122"/>
+                <a:sym typeface="Noto Sans SC" panose="020B0200000000000000" charset="-122"/>
+              </a:rPr>
+              <a:t>github</a:t>
+            </a:r>
+            <a:r>
+              <a:rPr lang="zh-CN" altLang="en-US" sz="2400" b="1" i="0" u="none" strike="noStrike">
+                <a:solidFill>
+                  <a:srgbClr val="000000"/>
+                </a:solidFill>
+                <a:latin typeface="Noto Sans SC" panose="020B0200000000000000" charset="-122"/>
+                <a:ea typeface="Noto Sans SC" panose="020B0200000000000000" charset="-122"/>
+                <a:cs typeface="Noto Sans SC" panose="020B0200000000000000" charset="-122"/>
+                <a:sym typeface="Noto Sans SC" panose="020B0200000000000000" charset="-122"/>
+              </a:rPr>
+              <a:t>项目</a:t>
+            </a:r>
+            <a:endParaRPr lang="zh-CN" altLang="en-US" sz="2400" b="1" i="0" u="none" strike="noStrike">
+              <a:solidFill>
+                <a:srgbClr val="000000"/>
+              </a:solidFill>
+              <a:latin typeface="Noto Sans SC" panose="020B0200000000000000" charset="-122"/>
+              <a:ea typeface="Noto Sans SC" panose="020B0200000000000000" charset="-122"/>
+              <a:cs typeface="Noto Sans SC" panose="020B0200000000000000" charset="-122"/>
+              <a:sym typeface="Noto Sans SC" panose="020B0200000000000000" charset="-122"/>
+            </a:endParaRPr>
+          </a:p>
+        </p:txBody>
+      </p:sp>
+      <p:sp>
+        <p:nvSpPr>
+          <p:cNvPr id="19" name="文本框 18"/>
+          <p:cNvSpPr txBox="1"/>
+          <p:nvPr/>
+        </p:nvSpPr>
+        <p:spPr>
+          <a:xfrm>
+            <a:off x="762000" y="1392555"/>
+            <a:ext cx="8422640" cy="1076325"/>
+          </a:xfrm>
+          <a:prstGeom prst="rect">
+            <a:avLst/>
+          </a:prstGeom>
+        </p:spPr>
+        <p:txBody>
+          <a:bodyPr wrap="square">
+            <a:spAutoFit/>
+          </a:bodyPr>
+          <a:p>
+            <a:r>
+              <a:rPr lang="en-US" altLang="zh-CN" sz="1600"/>
+              <a:t>https://github.com/lolorzlol/MADAO-GameCodingAssistant</a:t>
+            </a:r>
+            <a:endParaRPr lang="en-US" altLang="zh-CN" sz="1600"/>
+          </a:p>
+          <a:p>
+            <a:endParaRPr lang="en-US" altLang="zh-CN" sz="1600"/>
+          </a:p>
+          <a:p>
+            <a:r>
+              <a:rPr lang="zh-CN" altLang="en-US" sz="1600">
+                <a:ea typeface="宋体" panose="02010600030101010101" pitchFamily="2" charset="-122"/>
+              </a:rPr>
+              <a:t>包含</a:t>
+            </a:r>
+            <a:r>
+              <a:rPr lang="en-US" altLang="zh-CN" sz="1600">
+                <a:ea typeface="宋体" panose="02010600030101010101" pitchFamily="2" charset="-122"/>
+              </a:rPr>
+              <a:t>ppt</a:t>
+            </a:r>
+            <a:r>
+              <a:rPr lang="zh-CN" altLang="en-US" sz="1600">
+                <a:ea typeface="宋体" panose="02010600030101010101" pitchFamily="2" charset="-122"/>
+              </a:rPr>
+              <a:t>，文档等所有资料。</a:t>
+            </a:r>
+            <a:endParaRPr lang="en-US" altLang="zh-CN" sz="1600"/>
+          </a:p>
+          <a:p>
+            <a:endParaRPr lang="en-US" altLang="zh-CN" sz="1600"/>
           </a:p>
         </p:txBody>
       </p:sp>
@@ -18876,6 +20084,290 @@
 </file>
 
 <file path=ppt/theme/theme3.xml><?xml version="1.0" encoding="utf-8"?>
+<a:theme xmlns:a="http://schemas.openxmlformats.org/drawingml/2006/main" name="1_默认主题">
+  <a:themeElements>
+    <a:clrScheme name="Office">
+      <a:dk1>
+        <a:srgbClr val="000000"/>
+      </a:dk1>
+      <a:lt1>
+        <a:srgbClr val="FFFFFF"/>
+      </a:lt1>
+      <a:dk2>
+        <a:srgbClr val="44546A"/>
+      </a:dk2>
+      <a:lt2>
+        <a:srgbClr val="E7E6E6"/>
+      </a:lt2>
+      <a:accent1>
+        <a:srgbClr val="4472C4"/>
+      </a:accent1>
+      <a:accent2>
+        <a:srgbClr val="ED7D31"/>
+      </a:accent2>
+      <a:accent3>
+        <a:srgbClr val="A5A5A5"/>
+      </a:accent3>
+      <a:accent4>
+        <a:srgbClr val="FFC000"/>
+      </a:accent4>
+      <a:accent5>
+        <a:srgbClr val="5B9BD5"/>
+      </a:accent5>
+      <a:accent6>
+        <a:srgbClr val="70AD47"/>
+      </a:accent6>
+      <a:hlink>
+        <a:srgbClr val="0563C1"/>
+      </a:hlink>
+      <a:folHlink>
+        <a:srgbClr val="954F72"/>
+      </a:folHlink>
+    </a:clrScheme>
+    <a:fontScheme name="Office">
+      <a:majorFont>
+        <a:latin typeface="Arial"/>
+        <a:ea typeface=""/>
+        <a:cs typeface=""/>
+        <a:font script="Jpan" typeface="ＭＳ Ｐゴシック"/>
+        <a:font script="Hang" typeface="맑은 고딕"/>
+        <a:font script="Hans" typeface="宋体"/>
+        <a:font script="Hant" typeface="新細明體"/>
+        <a:font script="Arab" typeface="Times New Roman"/>
+        <a:font script="Hebr" typeface="Times New Roman"/>
+        <a:font script="Thai" typeface="Angsana New"/>
+        <a:font script="Ethi" typeface="Nyala"/>
+        <a:font script="Beng" typeface="Vrinda"/>
+        <a:font script="Gujr" typeface="Shruti"/>
+        <a:font script="Khmr" typeface="MoolBoran"/>
+        <a:font script="Knda" typeface="Tunga"/>
+        <a:font script="Guru" typeface="Raavi"/>
+        <a:font script="Cans" typeface="Euphemia"/>
+        <a:font script="Cher" typeface="Plantagenet Cherokee"/>
+        <a:font script="Yiii" typeface="Microsoft Yi Baiti"/>
+        <a:font script="Tibt" typeface="Microsoft Himalaya"/>
+        <a:font script="Thaa" typeface="MV Boli"/>
+        <a:font script="Deva" typeface="Mangal"/>
+        <a:font script="Telu" typeface="Gautami"/>
+        <a:font script="Taml" typeface="Latha"/>
+        <a:font script="Syrc" typeface="Estrangelo Edessa"/>
+        <a:font script="Orya" typeface="Kalinga"/>
+        <a:font script="Mlym" typeface="Kartika"/>
+        <a:font script="Laoo" typeface="DokChampa"/>
+        <a:font script="Sinh" typeface="Iskoola Pota"/>
+        <a:font script="Mong" typeface="Mongolian Baiti"/>
+        <a:font script="Viet" typeface="Times New Roman"/>
+        <a:font script="Uigh" typeface="Microsoft Uighur"/>
+        <a:font script="Geor" typeface="Sylfaen"/>
+      </a:majorFont>
+      <a:minorFont>
+        <a:latin typeface="Arial"/>
+        <a:ea typeface=""/>
+        <a:cs typeface=""/>
+        <a:font script="Jpan" typeface="ＭＳ Ｐゴシック"/>
+        <a:font script="Hang" typeface="맑은 고딕"/>
+        <a:font script="Hans" typeface="宋体"/>
+        <a:font script="Hant" typeface="新細明體"/>
+        <a:font script="Arab" typeface="Arial"/>
+        <a:font script="Hebr" typeface="Arial"/>
+        <a:font script="Thai" typeface="Cordia New"/>
+        <a:font script="Ethi" typeface="Nyala"/>
+        <a:font script="Beng" typeface="Vrinda"/>
+        <a:font script="Gujr" typeface="Shruti"/>
+        <a:font script="Khmr" typeface="DaunPenh"/>
+        <a:font script="Knda" typeface="Tunga"/>
+        <a:font script="Guru" typeface="Raavi"/>
+        <a:font script="Cans" typeface="Euphemia"/>
+        <a:font script="Cher" typeface="Plantagenet Cherokee"/>
+        <a:font script="Yiii" typeface="Microsoft Yi Baiti"/>
+        <a:font script="Tibt" typeface="Microsoft Himalaya"/>
+        <a:font script="Thaa" typeface="MV Boli"/>
+        <a:font script="Deva" typeface="Mangal"/>
+        <a:font script="Telu" typeface="Gautami"/>
+        <a:font script="Taml" typeface="Latha"/>
+        <a:font script="Syrc" typeface="Estrangelo Edessa"/>
+        <a:font script="Orya" typeface="Kalinga"/>
+        <a:font script="Mlym" typeface="Kartika"/>
+        <a:font script="Laoo" typeface="DokChampa"/>
+        <a:font script="Sinh" typeface="Iskoola Pota"/>
+        <a:font script="Mong" typeface="Mongolian Baiti"/>
+        <a:font script="Viet" typeface="Arial"/>
+        <a:font script="Uigh" typeface="Microsoft Uighur"/>
+        <a:font script="Geor" typeface="Sylfaen"/>
+      </a:minorFont>
+    </a:fontScheme>
+    <a:fmtScheme name="Office">
+      <a:fillStyleLst>
+        <a:solidFill>
+          <a:schemeClr val="phClr"/>
+        </a:solidFill>
+        <a:gradFill rotWithShape="1">
+          <a:gsLst>
+            <a:gs pos="0">
+              <a:schemeClr val="phClr">
+                <a:tint val="50000"/>
+                <a:satMod val="300000"/>
+              </a:schemeClr>
+            </a:gs>
+            <a:gs pos="35000">
+              <a:schemeClr val="phClr">
+                <a:tint val="37000"/>
+                <a:satMod val="300000"/>
+              </a:schemeClr>
+            </a:gs>
+            <a:gs pos="100000">
+              <a:schemeClr val="phClr">
+                <a:tint val="15000"/>
+                <a:satMod val="350000"/>
+              </a:schemeClr>
+            </a:gs>
+          </a:gsLst>
+          <a:lin ang="16200000" scaled="1"/>
+        </a:gradFill>
+        <a:gradFill rotWithShape="1">
+          <a:gsLst>
+            <a:gs pos="0">
+              <a:schemeClr val="phClr">
+                <a:tint val="100000"/>
+                <a:shade val="100000"/>
+                <a:satMod val="130000"/>
+              </a:schemeClr>
+            </a:gs>
+            <a:gs pos="100000">
+              <a:schemeClr val="phClr">
+                <a:tint val="50000"/>
+                <a:shade val="100000"/>
+                <a:satMod val="350000"/>
+              </a:schemeClr>
+            </a:gs>
+          </a:gsLst>
+          <a:lin ang="16200000" scaled="0"/>
+        </a:gradFill>
+      </a:fillStyleLst>
+      <a:lnStyleLst>
+        <a:ln w="9525" cap="flat" cmpd="sng" algn="ctr">
+          <a:solidFill>
+            <a:schemeClr val="phClr">
+              <a:shade val="95000"/>
+              <a:satMod val="105000"/>
+            </a:schemeClr>
+          </a:solidFill>
+          <a:prstDash val="solid"/>
+        </a:ln>
+        <a:ln w="25400" cap="flat" cmpd="sng" algn="ctr">
+          <a:solidFill>
+            <a:schemeClr val="phClr"/>
+          </a:solidFill>
+          <a:prstDash val="solid"/>
+        </a:ln>
+        <a:ln w="38100" cap="flat" cmpd="sng" algn="ctr">
+          <a:solidFill>
+            <a:schemeClr val="phClr"/>
+          </a:solidFill>
+          <a:prstDash val="solid"/>
+        </a:ln>
+      </a:lnStyleLst>
+      <a:effectStyleLst>
+        <a:effectStyle>
+          <a:effectLst>
+            <a:outerShdw blurRad="40000" dist="20000" dir="5400000" rotWithShape="0">
+              <a:srgbClr val="000000">
+                <a:alpha val="38000"/>
+              </a:srgbClr>
+            </a:outerShdw>
+          </a:effectLst>
+        </a:effectStyle>
+        <a:effectStyle>
+          <a:effectLst>
+            <a:outerShdw blurRad="40000" dist="23000" dir="5400000" rotWithShape="0">
+              <a:srgbClr val="000000">
+                <a:alpha val="35000"/>
+              </a:srgbClr>
+            </a:outerShdw>
+          </a:effectLst>
+        </a:effectStyle>
+        <a:effectStyle>
+          <a:effectLst>
+            <a:outerShdw blurRad="40000" dist="23000" dir="5400000" rotWithShape="0">
+              <a:srgbClr val="000000">
+                <a:alpha val="35000"/>
+              </a:srgbClr>
+            </a:outerShdw>
+          </a:effectLst>
+          <a:scene3d>
+            <a:camera prst="orthographicFront">
+              <a:rot lat="0" lon="0" rev="0"/>
+            </a:camera>
+            <a:lightRig rig="threePt" dir="t">
+              <a:rot lat="0" lon="0" rev="1200000"/>
+            </a:lightRig>
+          </a:scene3d>
+          <a:sp3d>
+            <a:bevelT w="63500" h="25400"/>
+          </a:sp3d>
+        </a:effectStyle>
+      </a:effectStyleLst>
+      <a:bgFillStyleLst>
+        <a:solidFill>
+          <a:schemeClr val="phClr"/>
+        </a:solidFill>
+        <a:gradFill rotWithShape="1">
+          <a:gsLst>
+            <a:gs pos="0">
+              <a:schemeClr val="phClr">
+                <a:tint val="40000"/>
+                <a:satMod val="350000"/>
+              </a:schemeClr>
+            </a:gs>
+            <a:gs pos="40000">
+              <a:schemeClr val="phClr">
+                <a:tint val="45000"/>
+                <a:shade val="99000"/>
+                <a:satMod val="350000"/>
+              </a:schemeClr>
+            </a:gs>
+            <a:gs pos="100000">
+              <a:schemeClr val="phClr">
+                <a:shade val="20000"/>
+                <a:satMod val="255000"/>
+              </a:schemeClr>
+            </a:gs>
+          </a:gsLst>
+          <a:path path="circle">
+            <a:fillToRect l="50000" t="-80000" r="50000" b="180000"/>
+          </a:path>
+        </a:gradFill>
+        <a:gradFill rotWithShape="1">
+          <a:gsLst>
+            <a:gs pos="0">
+              <a:schemeClr val="phClr">
+                <a:tint val="80000"/>
+                <a:satMod val="300000"/>
+              </a:schemeClr>
+            </a:gs>
+            <a:gs pos="100000">
+              <a:schemeClr val="phClr">
+                <a:shade val="30000"/>
+                <a:satMod val="200000"/>
+              </a:schemeClr>
+            </a:gs>
+          </a:gsLst>
+          <a:path path="circle">
+            <a:fillToRect l="50000" t="50000" r="50000" b="50000"/>
+          </a:path>
+        </a:gradFill>
+      </a:bgFillStyleLst>
+    </a:fmtScheme>
+  </a:themeElements>
+  <a:extLst>
+    <a:ext uri="{05A4C25C-085E-4340-85A3-A5531E510DB2}">
+      <thm15:themeFamily xmlns:thm15="http://schemas.microsoft.com/office/thememl/2012/main" name="Office Theme" id="{62F939B6-93AF-4DB8-9C6B-D6C7DFDC589F}" vid="{4A3C46E8-61CC-4603-A589-7422A47A8E4A}"/>
+    </a:ext>
+  </a:extLst>
+</a:theme>
+</file>
+
+<file path=ppt/theme/theme4.xml><?xml version="1.0" encoding="utf-8"?>
 <a:theme xmlns:a="http://schemas.openxmlformats.org/drawingml/2006/main" name="Office 主题​​">
   <a:themeElements>
     <a:clrScheme name="Office">

</xml_diff>